<commit_message>
Pushing intermediary updates and also testing git connection
</commit_message>
<xml_diff>
--- a/RSS-Climate-Slides-Template.pptx
+++ b/RSS-Climate-Slides-Template.pptx
@@ -202,7 +202,7 @@
           <a:p>
             <a:fld id="{F589267D-192F-45F4-B786-A6EED3B1BD13}" type="datetimeFigureOut">
               <a:rPr lang="en-US" smtClean="0"/>
-              <a:t>9/19/2025</a:t>
+              <a:t>9/22/2025</a:t>
             </a:fld>
             <a:endParaRPr lang="en-US"/>
           </a:p>
@@ -642,7 +642,7 @@
             <a:fld id="{2406883D-3F25-40E9-8AFB-BAE92341B8A6}" type="datetimeFigureOut">
               <a:rPr lang="en-US" smtClean="0"/>
               <a:pPr/>
-              <a:t>9/19/2025</a:t>
+              <a:t>9/22/2025</a:t>
             </a:fld>
             <a:endParaRPr lang="en-US"/>
           </a:p>
@@ -863,7 +863,7 @@
           <a:p>
             <a:fld id="{2406883D-3F25-40E9-8AFB-BAE92341B8A6}" type="datetimeFigureOut">
               <a:rPr lang="en-US" smtClean="0"/>
-              <a:t>9/19/2025</a:t>
+              <a:t>9/22/2025</a:t>
             </a:fld>
             <a:endParaRPr lang="en-US"/>
           </a:p>
@@ -1071,7 +1071,7 @@
           <a:p>
             <a:fld id="{2406883D-3F25-40E9-8AFB-BAE92341B8A6}" type="datetimeFigureOut">
               <a:rPr lang="en-US" smtClean="0"/>
-              <a:t>9/19/2025</a:t>
+              <a:t>9/22/2025</a:t>
             </a:fld>
             <a:endParaRPr lang="en-US"/>
           </a:p>
@@ -1285,7 +1285,7 @@
           <a:p>
             <a:fld id="{2406883D-3F25-40E9-8AFB-BAE92341B8A6}" type="datetimeFigureOut">
               <a:rPr lang="en-US" smtClean="0"/>
-              <a:t>9/19/2025</a:t>
+              <a:t>9/22/2025</a:t>
             </a:fld>
             <a:endParaRPr lang="en-US"/>
           </a:p>
@@ -1596,7 +1596,7 @@
           <a:p>
             <a:fld id="{2406883D-3F25-40E9-8AFB-BAE92341B8A6}" type="datetimeFigureOut">
               <a:rPr lang="en-US" smtClean="0"/>
-              <a:t>9/19/2025</a:t>
+              <a:t>9/22/2025</a:t>
             </a:fld>
             <a:endParaRPr lang="en-US"/>
           </a:p>
@@ -1871,7 +1871,7 @@
           <a:p>
             <a:fld id="{2406883D-3F25-40E9-8AFB-BAE92341B8A6}" type="datetimeFigureOut">
               <a:rPr lang="en-US" smtClean="0"/>
-              <a:t>9/19/2025</a:t>
+              <a:t>9/22/2025</a:t>
             </a:fld>
             <a:endParaRPr lang="en-US"/>
           </a:p>
@@ -2136,7 +2136,7 @@
           <a:p>
             <a:fld id="{2406883D-3F25-40E9-8AFB-BAE92341B8A6}" type="datetimeFigureOut">
               <a:rPr lang="en-US" smtClean="0"/>
-              <a:t>9/19/2025</a:t>
+              <a:t>9/22/2025</a:t>
             </a:fld>
             <a:endParaRPr lang="en-US"/>
           </a:p>
@@ -2548,7 +2548,7 @@
           <a:p>
             <a:fld id="{2406883D-3F25-40E9-8AFB-BAE92341B8A6}" type="datetimeFigureOut">
               <a:rPr lang="en-US" smtClean="0"/>
-              <a:t>9/19/2025</a:t>
+              <a:t>9/22/2025</a:t>
             </a:fld>
             <a:endParaRPr lang="en-US"/>
           </a:p>
@@ -2689,7 +2689,7 @@
           <a:p>
             <a:fld id="{2406883D-3F25-40E9-8AFB-BAE92341B8A6}" type="datetimeFigureOut">
               <a:rPr lang="en-US" smtClean="0"/>
-              <a:t>9/19/2025</a:t>
+              <a:t>9/22/2025</a:t>
             </a:fld>
             <a:endParaRPr lang="en-US"/>
           </a:p>
@@ -2802,7 +2802,7 @@
           <a:p>
             <a:fld id="{2406883D-3F25-40E9-8AFB-BAE92341B8A6}" type="datetimeFigureOut">
               <a:rPr lang="en-US" smtClean="0"/>
-              <a:t>9/19/2025</a:t>
+              <a:t>9/22/2025</a:t>
             </a:fld>
             <a:endParaRPr lang="en-US"/>
           </a:p>
@@ -3090,7 +3090,7 @@
           <a:p>
             <a:fld id="{2406883D-3F25-40E9-8AFB-BAE92341B8A6}" type="datetimeFigureOut">
               <a:rPr lang="en-US" smtClean="0"/>
-              <a:t>9/19/2025</a:t>
+              <a:t>9/22/2025</a:t>
             </a:fld>
             <a:endParaRPr lang="en-US"/>
           </a:p>
@@ -3336,7 +3336,7 @@
             <a:fld id="{2406883D-3F25-40E9-8AFB-BAE92341B8A6}" type="datetimeFigureOut">
               <a:rPr lang="en-US" smtClean="0"/>
               <a:pPr/>
-              <a:t>9/19/2025</a:t>
+              <a:t>9/22/2025</a:t>
             </a:fld>
             <a:endParaRPr lang="en-US"/>
           </a:p>
@@ -3435,6 +3435,42 @@
           </a:p>
         </p:txBody>
       </p:sp>
+      <p:pic>
+        <p:nvPicPr>
+          <p:cNvPr id="7" name="Picture 6">
+            <a:extLst>
+              <a:ext uri="{FF2B5EF4-FFF2-40B4-BE49-F238E27FC236}">
+                <a16:creationId xmlns:a16="http://schemas.microsoft.com/office/drawing/2014/main" id="{006A3888-69F2-5450-2643-DD0405A4CB41}"/>
+              </a:ext>
+            </a:extLst>
+          </p:cNvPr>
+          <p:cNvPicPr>
+            <a:picLocks noChangeAspect="1"/>
+          </p:cNvPicPr>
+          <p:nvPr userDrawn="1"/>
+        </p:nvPicPr>
+        <p:blipFill>
+          <a:blip r:embed="rId13" cstate="screen">
+            <a:extLst>
+              <a:ext uri="{28A0092B-C50C-407E-A947-70E740481C1C}">
+                <a14:useLocalDpi xmlns:a14="http://schemas.microsoft.com/office/drawing/2010/main"/>
+              </a:ext>
+            </a:extLst>
+          </a:blip>
+          <a:stretch>
+            <a:fillRect/>
+          </a:stretch>
+        </p:blipFill>
+        <p:spPr>
+          <a:xfrm>
+            <a:off x="11539601" y="72890"/>
+            <a:ext cx="467724" cy="610602"/>
+          </a:xfrm>
+          <a:prstGeom prst="rect">
+            <a:avLst/>
+          </a:prstGeom>
+        </p:spPr>
+      </p:pic>
     </p:spTree>
     <p:extLst>
       <p:ext uri="{BB962C8B-B14F-4D97-AF65-F5344CB8AC3E}">

</xml_diff>

<commit_message>
Updated PPT template required to run markdown
</commit_message>
<xml_diff>
--- a/RSS-Climate-Slides-Template.pptx
+++ b/RSS-Climate-Slides-Template.pptx
@@ -202,7 +202,7 @@
           <a:p>
             <a:fld id="{F589267D-192F-45F4-B786-A6EED3B1BD13}" type="datetimeFigureOut">
               <a:rPr lang="en-US" smtClean="0"/>
-              <a:t>9/22/2025</a:t>
+              <a:t>12/17/2025</a:t>
             </a:fld>
             <a:endParaRPr lang="en-US"/>
           </a:p>
@@ -509,7 +509,7 @@
           </a:xfrm>
         </p:spPr>
         <p:txBody>
-          <a:bodyPr anchor="ctr"/>
+          <a:bodyPr anchor="b"/>
           <a:lstStyle>
             <a:lvl1pPr algn="ctr">
               <a:defRPr sz="6000">
@@ -601,7 +601,7 @@
           </a:lstStyle>
           <a:p>
             <a:r>
-              <a:rPr lang="en-US"/>
+              <a:rPr lang="en-US" dirty="0"/>
               <a:t>Click to edit Master subtitle style</a:t>
             </a:r>
           </a:p>
@@ -628,7 +628,7 @@
           <a:bodyPr/>
           <a:lstStyle>
             <a:lvl1pPr>
-              <a:defRPr>
+              <a:defRPr sz="1600">
                 <a:solidFill>
                   <a:schemeClr val="bg1"/>
                 </a:solidFill>
@@ -642,9 +642,9 @@
             <a:fld id="{2406883D-3F25-40E9-8AFB-BAE92341B8A6}" type="datetimeFigureOut">
               <a:rPr lang="en-US" smtClean="0"/>
               <a:pPr/>
-              <a:t>9/22/2025</a:t>
+              <a:t>12/17/2025</a:t>
             </a:fld>
-            <a:endParaRPr lang="en-US"/>
+            <a:endParaRPr lang="en-US" dirty="0"/>
           </a:p>
         </p:txBody>
       </p:sp>
@@ -863,7 +863,7 @@
           <a:p>
             <a:fld id="{2406883D-3F25-40E9-8AFB-BAE92341B8A6}" type="datetimeFigureOut">
               <a:rPr lang="en-US" smtClean="0"/>
-              <a:t>9/22/2025</a:t>
+              <a:t>12/17/2025</a:t>
             </a:fld>
             <a:endParaRPr lang="en-US"/>
           </a:p>
@@ -1071,7 +1071,7 @@
           <a:p>
             <a:fld id="{2406883D-3F25-40E9-8AFB-BAE92341B8A6}" type="datetimeFigureOut">
               <a:rPr lang="en-US" smtClean="0"/>
-              <a:t>9/22/2025</a:t>
+              <a:t>12/17/2025</a:t>
             </a:fld>
             <a:endParaRPr lang="en-US"/>
           </a:p>
@@ -1285,7 +1285,7 @@
           <a:p>
             <a:fld id="{2406883D-3F25-40E9-8AFB-BAE92341B8A6}" type="datetimeFigureOut">
               <a:rPr lang="en-US" smtClean="0"/>
-              <a:t>9/22/2025</a:t>
+              <a:t>12/17/2025</a:t>
             </a:fld>
             <a:endParaRPr lang="en-US"/>
           </a:p>
@@ -1393,12 +1393,14 @@
         </p:nvSpPr>
         <p:spPr>
           <a:xfrm>
-            <a:off x="839788" y="457200"/>
-            <a:ext cx="3932237" cy="1600200"/>
+            <a:off x="480847" y="457199"/>
+            <a:ext cx="11067393" cy="902031"/>
           </a:xfrm>
         </p:spPr>
         <p:txBody>
-          <a:bodyPr anchor="t"/>
+          <a:bodyPr anchor="t">
+            <a:normAutofit/>
+          </a:bodyPr>
           <a:lstStyle>
             <a:lvl1pPr algn="l">
               <a:defRPr sz="3200"/>
@@ -1430,8 +1432,8 @@
         </p:nvSpPr>
         <p:spPr>
           <a:xfrm>
-            <a:off x="5183188" y="457200"/>
-            <a:ext cx="6172200" cy="5411787"/>
+            <a:off x="2528280" y="2115972"/>
+            <a:ext cx="7135439" cy="4181462"/>
           </a:xfrm>
         </p:spPr>
         <p:txBody>
@@ -1520,16 +1522,18 @@
         </p:nvSpPr>
         <p:spPr>
           <a:xfrm>
-            <a:off x="839788" y="2057400"/>
-            <a:ext cx="3932237" cy="3811588"/>
+            <a:off x="477670" y="1417803"/>
+            <a:ext cx="11067393" cy="639596"/>
           </a:xfrm>
         </p:spPr>
         <p:txBody>
-          <a:bodyPr/>
+          <a:bodyPr>
+            <a:normAutofit/>
+          </a:bodyPr>
           <a:lstStyle>
             <a:lvl1pPr marL="0" indent="0">
               <a:buNone/>
-              <a:defRPr sz="1600"/>
+              <a:defRPr sz="2000"/>
             </a:lvl1pPr>
             <a:lvl2pPr marL="457200" indent="0">
               <a:buNone/>
@@ -1596,7 +1600,7 @@
           <a:p>
             <a:fld id="{2406883D-3F25-40E9-8AFB-BAE92341B8A6}" type="datetimeFigureOut">
               <a:rPr lang="en-US" smtClean="0"/>
-              <a:t>9/22/2025</a:t>
+              <a:t>12/17/2025</a:t>
             </a:fld>
             <a:endParaRPr lang="en-US"/>
           </a:p>
@@ -1709,9 +1713,9 @@
           </a:xfrm>
         </p:spPr>
         <p:txBody>
-          <a:bodyPr anchor="b"/>
+          <a:bodyPr anchor="ctr" anchorCtr="0"/>
           <a:lstStyle>
-            <a:lvl1pPr>
+            <a:lvl1pPr algn="ctr">
               <a:defRPr sz="6000"/>
             </a:lvl1pPr>
           </a:lstStyle>
@@ -1871,7 +1875,7 @@
           <a:p>
             <a:fld id="{2406883D-3F25-40E9-8AFB-BAE92341B8A6}" type="datetimeFigureOut">
               <a:rPr lang="en-US" smtClean="0"/>
-              <a:t>9/22/2025</a:t>
+              <a:t>12/17/2025</a:t>
             </a:fld>
             <a:endParaRPr lang="en-US"/>
           </a:p>
@@ -1941,6 +1945,7 @@
   <p:clrMapOvr>
     <a:masterClrMapping/>
   </p:clrMapOvr>
+  <p:hf hdr="0" ftr="0" dt="0"/>
 </p:sldLayout>
 </file>
 
@@ -2136,7 +2141,7 @@
           <a:p>
             <a:fld id="{2406883D-3F25-40E9-8AFB-BAE92341B8A6}" type="datetimeFigureOut">
               <a:rPr lang="en-US" smtClean="0"/>
-              <a:t>9/22/2025</a:t>
+              <a:t>12/17/2025</a:t>
             </a:fld>
             <a:endParaRPr lang="en-US"/>
           </a:p>
@@ -2548,7 +2553,7 @@
           <a:p>
             <a:fld id="{2406883D-3F25-40E9-8AFB-BAE92341B8A6}" type="datetimeFigureOut">
               <a:rPr lang="en-US" smtClean="0"/>
-              <a:t>9/22/2025</a:t>
+              <a:t>12/17/2025</a:t>
             </a:fld>
             <a:endParaRPr lang="en-US"/>
           </a:p>
@@ -2689,7 +2694,7 @@
           <a:p>
             <a:fld id="{2406883D-3F25-40E9-8AFB-BAE92341B8A6}" type="datetimeFigureOut">
               <a:rPr lang="en-US" smtClean="0"/>
-              <a:t>9/22/2025</a:t>
+              <a:t>12/17/2025</a:t>
             </a:fld>
             <a:endParaRPr lang="en-US"/>
           </a:p>
@@ -2802,7 +2807,7 @@
           <a:p>
             <a:fld id="{2406883D-3F25-40E9-8AFB-BAE92341B8A6}" type="datetimeFigureOut">
               <a:rPr lang="en-US" smtClean="0"/>
-              <a:t>9/22/2025</a:t>
+              <a:t>12/17/2025</a:t>
             </a:fld>
             <a:endParaRPr lang="en-US"/>
           </a:p>
@@ -3090,7 +3095,7 @@
           <a:p>
             <a:fld id="{2406883D-3F25-40E9-8AFB-BAE92341B8A6}" type="datetimeFigureOut">
               <a:rPr lang="en-US" smtClean="0"/>
-              <a:t>9/22/2025</a:t>
+              <a:t>12/17/2025</a:t>
             </a:fld>
             <a:endParaRPr lang="en-US"/>
           </a:p>
@@ -3220,7 +3225,7 @@
           <a:lstStyle/>
           <a:p>
             <a:r>
-              <a:rPr lang="en-US"/>
+              <a:rPr lang="en-US" dirty="0"/>
               <a:t>Click to edit Master title style</a:t>
             </a:r>
           </a:p>
@@ -3336,7 +3341,7 @@
             <a:fld id="{2406883D-3F25-40E9-8AFB-BAE92341B8A6}" type="datetimeFigureOut">
               <a:rPr lang="en-US" smtClean="0"/>
               <a:pPr/>
-              <a:t>9/22/2025</a:t>
+              <a:t>12/17/2025</a:t>
             </a:fld>
             <a:endParaRPr lang="en-US"/>
           </a:p>
@@ -3954,10 +3959,10 @@
       </p:grpSpPr>
       <p:sp>
         <p:nvSpPr>
-          <p:cNvPr id="2" name="Title 1">
-            <a:extLst>
-              <a:ext uri="{FF2B5EF4-FFF2-40B4-BE49-F238E27FC236}">
-                <a16:creationId xmlns:a16="http://schemas.microsoft.com/office/drawing/2014/main" id="{FD8B9572-40D5-DE38-A60C-2E963EB61703}"/>
+          <p:cNvPr id="4" name="Title 3">
+            <a:extLst>
+              <a:ext uri="{FF2B5EF4-FFF2-40B4-BE49-F238E27FC236}">
+                <a16:creationId xmlns:a16="http://schemas.microsoft.com/office/drawing/2014/main" id="{A72F6A06-B442-3293-24FD-5570EA31D144}"/>
               </a:ext>
             </a:extLst>
           </p:cNvPr>
@@ -3973,16 +3978,16 @@
           <a:bodyPr/>
           <a:lstStyle/>
           <a:p>
-            <a:endParaRPr lang="en-US" dirty="0"/>
-          </a:p>
-        </p:txBody>
-      </p:sp>
-      <p:sp>
-        <p:nvSpPr>
-          <p:cNvPr id="3" name="Content Placeholder 2">
-            <a:extLst>
-              <a:ext uri="{FF2B5EF4-FFF2-40B4-BE49-F238E27FC236}">
-                <a16:creationId xmlns:a16="http://schemas.microsoft.com/office/drawing/2014/main" id="{EC30432F-47D5-F87E-9157-52564935D5C7}"/>
+            <a:endParaRPr lang="en-US"/>
+          </a:p>
+        </p:txBody>
+      </p:sp>
+      <p:sp>
+        <p:nvSpPr>
+          <p:cNvPr id="5" name="Content Placeholder 4">
+            <a:extLst>
+              <a:ext uri="{FF2B5EF4-FFF2-40B4-BE49-F238E27FC236}">
+                <a16:creationId xmlns:a16="http://schemas.microsoft.com/office/drawing/2014/main" id="{1EAFAE17-8400-0BF5-E8AF-3F040CA23E82}"/>
               </a:ext>
             </a:extLst>
           </p:cNvPr>
@@ -3998,16 +4003,16 @@
           <a:bodyPr/>
           <a:lstStyle/>
           <a:p>
-            <a:endParaRPr lang="en-US" dirty="0"/>
-          </a:p>
-        </p:txBody>
-      </p:sp>
-      <p:sp>
-        <p:nvSpPr>
-          <p:cNvPr id="4" name="Text Placeholder 3">
-            <a:extLst>
-              <a:ext uri="{FF2B5EF4-FFF2-40B4-BE49-F238E27FC236}">
-                <a16:creationId xmlns:a16="http://schemas.microsoft.com/office/drawing/2014/main" id="{37A06642-A642-C3A5-B5C4-4DA5748C9FE0}"/>
+            <a:endParaRPr lang="en-US"/>
+          </a:p>
+        </p:txBody>
+      </p:sp>
+      <p:sp>
+        <p:nvSpPr>
+          <p:cNvPr id="6" name="Text Placeholder 5">
+            <a:extLst>
+              <a:ext uri="{FF2B5EF4-FFF2-40B4-BE49-F238E27FC236}">
+                <a16:creationId xmlns:a16="http://schemas.microsoft.com/office/drawing/2014/main" id="{C027B1B2-145A-C0FB-1B13-67FDED8BA990}"/>
               </a:ext>
             </a:extLst>
           </p:cNvPr>
@@ -4023,14 +4028,14 @@
           <a:bodyPr/>
           <a:lstStyle/>
           <a:p>
-            <a:endParaRPr lang="en-US" dirty="0"/>
+            <a:endParaRPr lang="en-US"/>
           </a:p>
         </p:txBody>
       </p:sp>
     </p:spTree>
     <p:extLst>
       <p:ext uri="{BB962C8B-B14F-4D97-AF65-F5344CB8AC3E}">
-        <p14:creationId xmlns:p14="http://schemas.microsoft.com/office/powerpoint/2010/main" val="78804757"/>
+        <p14:creationId xmlns:p14="http://schemas.microsoft.com/office/powerpoint/2010/main" val="384903634"/>
       </p:ext>
     </p:extLst>
   </p:cSld>

</xml_diff>